<commit_message>
Power point presentation added.
</commit_message>
<xml_diff>
--- a/slides/Farhans_OOPS_Project_CourseRegistrationSystem.pptx
+++ b/slides/Farhans_OOPS_Project_CourseRegistrationSystem.pptx
@@ -7,9 +7,10 @@
   <p:sldIdLst>
     <p:sldId id="256" r:id="rId2"/>
     <p:sldId id="257" r:id="rId3"/>
-    <p:sldId id="258" r:id="rId4"/>
-    <p:sldId id="259" r:id="rId5"/>
-    <p:sldId id="260" r:id="rId6"/>
+    <p:sldId id="261" r:id="rId4"/>
+    <p:sldId id="258" r:id="rId5"/>
+    <p:sldId id="259" r:id="rId6"/>
+    <p:sldId id="260" r:id="rId7"/>
   </p:sldIdLst>
   <p:sldSz cx="12192000" cy="6858000"/>
   <p:notesSz cx="6858000" cy="9144000"/>
@@ -108,6 +109,11 @@
       </a:defRPr>
     </a:lvl9pPr>
   </p:defaultTextStyle>
+  <p:extLst>
+    <p:ext uri="{EFAFB233-063F-42B5-8137-9DF3F51BA10A}">
+      <p15:sldGuideLst xmlns:p15="http://schemas.microsoft.com/office/powerpoint/2012/main"/>
+    </p:ext>
+  </p:extLst>
 </p:presentation>
 </file>
 
@@ -260,7 +266,7 @@
           <a:p>
             <a:fld id="{40A82806-6913-4916-B112-D3DE1E7D96EF}" type="datetimeFigureOut">
               <a:rPr lang="en-IN" smtClean="0"/>
-              <a:t>28-03-2026</a:t>
+              <a:t>29-03-2026</a:t>
             </a:fld>
             <a:endParaRPr lang="en-IN"/>
           </a:p>
@@ -460,7 +466,7 @@
           <a:p>
             <a:fld id="{40A82806-6913-4916-B112-D3DE1E7D96EF}" type="datetimeFigureOut">
               <a:rPr lang="en-IN" smtClean="0"/>
-              <a:t>28-03-2026</a:t>
+              <a:t>29-03-2026</a:t>
             </a:fld>
             <a:endParaRPr lang="en-IN"/>
           </a:p>
@@ -670,7 +676,7 @@
           <a:p>
             <a:fld id="{40A82806-6913-4916-B112-D3DE1E7D96EF}" type="datetimeFigureOut">
               <a:rPr lang="en-IN" smtClean="0"/>
-              <a:t>28-03-2026</a:t>
+              <a:t>29-03-2026</a:t>
             </a:fld>
             <a:endParaRPr lang="en-IN"/>
           </a:p>
@@ -870,7 +876,7 @@
           <a:p>
             <a:fld id="{40A82806-6913-4916-B112-D3DE1E7D96EF}" type="datetimeFigureOut">
               <a:rPr lang="en-IN" smtClean="0"/>
-              <a:t>28-03-2026</a:t>
+              <a:t>29-03-2026</a:t>
             </a:fld>
             <a:endParaRPr lang="en-IN"/>
           </a:p>
@@ -1146,7 +1152,7 @@
           <a:p>
             <a:fld id="{40A82806-6913-4916-B112-D3DE1E7D96EF}" type="datetimeFigureOut">
               <a:rPr lang="en-IN" smtClean="0"/>
-              <a:t>28-03-2026</a:t>
+              <a:t>29-03-2026</a:t>
             </a:fld>
             <a:endParaRPr lang="en-IN"/>
           </a:p>
@@ -1414,7 +1420,7 @@
           <a:p>
             <a:fld id="{40A82806-6913-4916-B112-D3DE1E7D96EF}" type="datetimeFigureOut">
               <a:rPr lang="en-IN" smtClean="0"/>
-              <a:t>28-03-2026</a:t>
+              <a:t>29-03-2026</a:t>
             </a:fld>
             <a:endParaRPr lang="en-IN"/>
           </a:p>
@@ -1829,7 +1835,7 @@
           <a:p>
             <a:fld id="{40A82806-6913-4916-B112-D3DE1E7D96EF}" type="datetimeFigureOut">
               <a:rPr lang="en-IN" smtClean="0"/>
-              <a:t>28-03-2026</a:t>
+              <a:t>29-03-2026</a:t>
             </a:fld>
             <a:endParaRPr lang="en-IN"/>
           </a:p>
@@ -1971,7 +1977,7 @@
           <a:p>
             <a:fld id="{40A82806-6913-4916-B112-D3DE1E7D96EF}" type="datetimeFigureOut">
               <a:rPr lang="en-IN" smtClean="0"/>
-              <a:t>28-03-2026</a:t>
+              <a:t>29-03-2026</a:t>
             </a:fld>
             <a:endParaRPr lang="en-IN"/>
           </a:p>
@@ -2084,7 +2090,7 @@
           <a:p>
             <a:fld id="{40A82806-6913-4916-B112-D3DE1E7D96EF}" type="datetimeFigureOut">
               <a:rPr lang="en-IN" smtClean="0"/>
-              <a:t>28-03-2026</a:t>
+              <a:t>29-03-2026</a:t>
             </a:fld>
             <a:endParaRPr lang="en-IN"/>
           </a:p>
@@ -2397,7 +2403,7 @@
           <a:p>
             <a:fld id="{40A82806-6913-4916-B112-D3DE1E7D96EF}" type="datetimeFigureOut">
               <a:rPr lang="en-IN" smtClean="0"/>
-              <a:t>28-03-2026</a:t>
+              <a:t>29-03-2026</a:t>
             </a:fld>
             <a:endParaRPr lang="en-IN"/>
           </a:p>
@@ -2686,7 +2692,7 @@
           <a:p>
             <a:fld id="{40A82806-6913-4916-B112-D3DE1E7D96EF}" type="datetimeFigureOut">
               <a:rPr lang="en-IN" smtClean="0"/>
-              <a:t>28-03-2026</a:t>
+              <a:t>29-03-2026</a:t>
             </a:fld>
             <a:endParaRPr lang="en-IN"/>
           </a:p>
@@ -2929,7 +2935,7 @@
           <a:p>
             <a:fld id="{40A82806-6913-4916-B112-D3DE1E7D96EF}" type="datetimeFigureOut">
               <a:rPr lang="en-IN" smtClean="0"/>
-              <a:t>28-03-2026</a:t>
+              <a:t>29-03-2026</a:t>
             </a:fld>
             <a:endParaRPr lang="en-IN"/>
           </a:p>
@@ -3572,6 +3578,46 @@
               </a:rPr>
               <a:t>System Design</a:t>
             </a:r>
+            <a:br>
+              <a:rPr lang="en-IN" sz="3000" b="1" dirty="0">
+                <a:solidFill>
+                  <a:schemeClr val="tx2">
+                    <a:lumMod val="50000"/>
+                    <a:lumOff val="50000"/>
+                  </a:schemeClr>
+                </a:solidFill>
+                <a:highlight>
+                  <a:srgbClr val="FFFF00"/>
+                </a:highlight>
+              </a:rPr>
+            </a:br>
+            <a:r>
+              <a:rPr lang="en-IN" sz="3000" b="1" dirty="0">
+                <a:solidFill>
+                  <a:schemeClr val="tx2">
+                    <a:lumMod val="50000"/>
+                    <a:lumOff val="50000"/>
+                  </a:schemeClr>
+                </a:solidFill>
+                <a:highlight>
+                  <a:srgbClr val="FFFF00"/>
+                </a:highlight>
+              </a:rPr>
+              <a:t>High Level Architecture Diagram:</a:t>
+            </a:r>
+            <a:br>
+              <a:rPr lang="en-IN" sz="3000" b="1" dirty="0">
+                <a:solidFill>
+                  <a:schemeClr val="tx2">
+                    <a:lumMod val="50000"/>
+                    <a:lumOff val="50000"/>
+                  </a:schemeClr>
+                </a:solidFill>
+                <a:highlight>
+                  <a:srgbClr val="FFFF00"/>
+                </a:highlight>
+              </a:rPr>
+            </a:br>
             <a:endParaRPr lang="en-IN" sz="3000" dirty="0">
               <a:solidFill>
                 <a:schemeClr val="tx2">
@@ -3586,210 +3632,44 @@
           </a:p>
         </p:txBody>
       </p:sp>
-      <p:sp>
-        <p:nvSpPr>
-          <p:cNvPr id="3" name="Content Placeholder 2">
-            <a:extLst>
-              <a:ext uri="{FF2B5EF4-FFF2-40B4-BE49-F238E27FC236}">
-                <a16:creationId xmlns:a16="http://schemas.microsoft.com/office/drawing/2014/main" id="{F79A185E-6A14-2099-53CE-D7EE9593F94A}"/>
-              </a:ext>
-            </a:extLst>
-          </p:cNvPr>
-          <p:cNvSpPr>
-            <a:spLocks noGrp="1"/>
-          </p:cNvSpPr>
+      <p:pic>
+        <p:nvPicPr>
+          <p:cNvPr id="7" name="Content Placeholder 6" descr="The diagram illustrates a course registration system architecture using Java, highlighting the layers: Presentation, Application, Design, and Data, and detailing their roles in managing user interaction, course registration, validation, credit calculation, and data storage.&#10;&#10;AI-generated content may be incorrect.">
+            <a:extLst>
+              <a:ext uri="{FF2B5EF4-FFF2-40B4-BE49-F238E27FC236}">
+                <a16:creationId xmlns:a16="http://schemas.microsoft.com/office/drawing/2014/main" id="{07028768-727F-B9E4-0197-DCB997772553}"/>
+              </a:ext>
+            </a:extLst>
+          </p:cNvPr>
+          <p:cNvPicPr>
+            <a:picLocks noGrp="1" noChangeAspect="1"/>
+          </p:cNvPicPr>
           <p:nvPr>
             <p:ph idx="1"/>
           </p:nvPr>
-        </p:nvSpPr>
+        </p:nvPicPr>
+        <p:blipFill>
+          <a:blip r:embed="rId2">
+            <a:extLst>
+              <a:ext uri="{28A0092B-C50C-407E-A947-70E740481C1C}">
+                <a14:useLocalDpi xmlns:a14="http://schemas.microsoft.com/office/drawing/2010/main" val="0"/>
+              </a:ext>
+            </a:extLst>
+          </a:blip>
+          <a:stretch>
+            <a:fillRect/>
+          </a:stretch>
+        </p:blipFill>
         <p:spPr>
           <a:xfrm>
-            <a:off x="906439" y="1170533"/>
-            <a:ext cx="10515600" cy="5414512"/>
+            <a:off x="1200548" y="1169988"/>
+            <a:ext cx="9927430" cy="5414962"/>
           </a:xfrm>
+          <a:prstGeom prst="rect">
+            <a:avLst/>
+          </a:prstGeom>
         </p:spPr>
-        <p:txBody>
-          <a:bodyPr>
-            <a:normAutofit lnSpcReduction="10000"/>
-          </a:bodyPr>
-          <a:lstStyle/>
-          <a:p>
-            <a:r>
-              <a:rPr lang="en-US" sz="2000" b="1" dirty="0"/>
-              <a:t>High-Level Architecture:</a:t>
-            </a:r>
-            <a:br>
-              <a:rPr lang="en-US" sz="2000" dirty="0"/>
-            </a:br>
-            <a:r>
-              <a:rPr lang="en-US" sz="2000" dirty="0"/>
-              <a:t>User interacts with a menu-driven interface → system processes input → manages course selection using Composite Pattern.</a:t>
-            </a:r>
-          </a:p>
-          <a:p>
-            <a:r>
-              <a:rPr lang="fr-FR" dirty="0"/>
-              <a:t>User → Menu System → Course Modules (Composite Structure)</a:t>
-            </a:r>
-          </a:p>
-          <a:p>
-            <a:r>
-              <a:rPr lang="en-US" sz="2000" b="1" dirty="0"/>
-              <a:t>Key Classes &amp; Responsibilities:</a:t>
-            </a:r>
-            <a:endParaRPr lang="en-US" sz="2000" dirty="0"/>
-          </a:p>
-          <a:p>
-            <a:r>
-              <a:rPr lang="en-US" sz="2000" b="1" dirty="0" err="1"/>
-              <a:t>CourseModule</a:t>
-            </a:r>
-            <a:r>
-              <a:rPr lang="en-US" sz="2000" b="1" dirty="0"/>
-              <a:t> (Interface):</a:t>
-            </a:r>
-            <a:r>
-              <a:rPr lang="en-US" sz="2000" dirty="0"/>
-              <a:t> Defines common operations like </a:t>
-            </a:r>
-            <a:r>
-              <a:rPr lang="en-US" sz="2000" dirty="0" err="1"/>
-              <a:t>showDetails</a:t>
-            </a:r>
-            <a:r>
-              <a:rPr lang="en-US" sz="2000" dirty="0"/>
-              <a:t>() and </a:t>
-            </a:r>
-            <a:r>
-              <a:rPr lang="en-US" sz="2000" dirty="0" err="1"/>
-              <a:t>getCredits</a:t>
-            </a:r>
-            <a:r>
-              <a:rPr lang="en-US" sz="2000" dirty="0"/>
-              <a:t>() </a:t>
-            </a:r>
-          </a:p>
-          <a:p>
-            <a:r>
-              <a:rPr lang="en-US" sz="2000" b="1" dirty="0" err="1"/>
-              <a:t>IndividualCourse</a:t>
-            </a:r>
-            <a:r>
-              <a:rPr lang="en-US" sz="2000" b="1" dirty="0"/>
-              <a:t> (Leaf):</a:t>
-            </a:r>
-            <a:r>
-              <a:rPr lang="en-US" sz="2000" dirty="0"/>
-              <a:t> Represents a single course with name and credits </a:t>
-            </a:r>
-          </a:p>
-          <a:p>
-            <a:r>
-              <a:rPr lang="en-US" sz="2000" b="1" dirty="0" err="1"/>
-              <a:t>CourseGroup</a:t>
-            </a:r>
-            <a:r>
-              <a:rPr lang="en-US" sz="2000" b="1" dirty="0"/>
-              <a:t> (Composite):</a:t>
-            </a:r>
-            <a:r>
-              <a:rPr lang="en-US" sz="2000" dirty="0"/>
-              <a:t> Groups multiple courses/modules and manages them </a:t>
-            </a:r>
-          </a:p>
-          <a:p>
-            <a:r>
-              <a:rPr lang="en-US" sz="2000" b="1" dirty="0"/>
-              <a:t>Package Structure:</a:t>
-            </a:r>
-            <a:endParaRPr lang="en-US" sz="2000" dirty="0"/>
-          </a:p>
-          <a:p>
-            <a:r>
-              <a:rPr lang="en-US" sz="2000" b="1" dirty="0"/>
-              <a:t>model:</a:t>
-            </a:r>
-            <a:r>
-              <a:rPr lang="en-US" sz="2000" dirty="0"/>
-              <a:t> Contains </a:t>
-            </a:r>
-            <a:r>
-              <a:rPr lang="en-US" sz="2000" dirty="0" err="1"/>
-              <a:t>CourseModule</a:t>
-            </a:r>
-            <a:r>
-              <a:rPr lang="en-US" sz="2000" dirty="0"/>
-              <a:t>, </a:t>
-            </a:r>
-            <a:r>
-              <a:rPr lang="en-US" sz="2000" dirty="0" err="1"/>
-              <a:t>IndividualCourse</a:t>
-            </a:r>
-            <a:r>
-              <a:rPr lang="en-US" sz="2000" dirty="0"/>
-              <a:t>, </a:t>
-            </a:r>
-            <a:r>
-              <a:rPr lang="en-US" sz="2000" dirty="0" err="1"/>
-              <a:t>CourseGroup</a:t>
-            </a:r>
-            <a:r>
-              <a:rPr lang="en-US" sz="2000" dirty="0"/>
-              <a:t> </a:t>
-            </a:r>
-          </a:p>
-          <a:p>
-            <a:r>
-              <a:rPr lang="en-US" sz="2000" b="1" dirty="0"/>
-              <a:t>main:</a:t>
-            </a:r>
-            <a:r>
-              <a:rPr lang="en-US" sz="2000" dirty="0"/>
-              <a:t> Contains </a:t>
-            </a:r>
-            <a:r>
-              <a:rPr lang="en-US" sz="2000" dirty="0" err="1"/>
-              <a:t>CourseRegistrationSystem</a:t>
-            </a:r>
-            <a:r>
-              <a:rPr lang="en-US" sz="2000" dirty="0"/>
-              <a:t> (execution logic) </a:t>
-            </a:r>
-          </a:p>
-          <a:p>
-            <a:r>
-              <a:rPr lang="en-IN" dirty="0"/>
-              <a:t> </a:t>
-            </a:r>
-            <a:r>
-              <a:rPr lang="en-IN" dirty="0" err="1"/>
-              <a:t>CourseModule</a:t>
-            </a:r>
-            <a:endParaRPr lang="en-IN" dirty="0"/>
-          </a:p>
-          <a:p>
-            <a:r>
-              <a:rPr lang="en-IN" dirty="0"/>
-              <a:t>        /                         \</a:t>
-            </a:r>
-          </a:p>
-          <a:p>
-            <a:r>
-              <a:rPr lang="en-IN" dirty="0" err="1"/>
-              <a:t>IndividualCourse</a:t>
-            </a:r>
-            <a:r>
-              <a:rPr lang="en-IN" dirty="0"/>
-              <a:t>  </a:t>
-            </a:r>
-            <a:r>
-              <a:rPr lang="en-IN" dirty="0" err="1"/>
-              <a:t>CourseGroup</a:t>
-            </a:r>
-            <a:endParaRPr lang="en-IN" dirty="0"/>
-          </a:p>
-        </p:txBody>
-      </p:sp>
+      </p:pic>
     </p:spTree>
     <p:extLst>
       <p:ext uri="{BB962C8B-B14F-4D97-AF65-F5344CB8AC3E}">
@@ -3825,7 +3705,7 @@
           <p:cNvPr id="2" name="Title 1">
             <a:extLst>
               <a:ext uri="{FF2B5EF4-FFF2-40B4-BE49-F238E27FC236}">
-                <a16:creationId xmlns:a16="http://schemas.microsoft.com/office/drawing/2014/main" id="{E1750AAE-FF6D-7309-8E46-CE96AA596D16}"/>
+                <a16:creationId xmlns:a16="http://schemas.microsoft.com/office/drawing/2014/main" id="{D5AA8C2C-A330-2505-AB0E-2C374AAF2B1B}"/>
               </a:ext>
             </a:extLst>
           </p:cNvPr>
@@ -3834,219 +3714,219 @@
           </p:cNvSpPr>
           <p:nvPr>
             <p:ph type="title"/>
+          </p:nvPr>
+        </p:nvSpPr>
+        <p:spPr/>
+        <p:txBody>
+          <a:bodyPr>
+            <a:normAutofit/>
+          </a:bodyPr>
+          <a:lstStyle/>
+          <a:p>
+            <a:r>
+              <a:rPr lang="en-US" sz="2800" b="1" dirty="0"/>
+              <a:t>High-Level Architecture:</a:t>
+            </a:r>
+            <a:endParaRPr lang="en-IN" sz="2800" dirty="0"/>
+          </a:p>
+        </p:txBody>
+      </p:sp>
+      <p:sp>
+        <p:nvSpPr>
+          <p:cNvPr id="3" name="Content Placeholder 2">
+            <a:extLst>
+              <a:ext uri="{FF2B5EF4-FFF2-40B4-BE49-F238E27FC236}">
+                <a16:creationId xmlns:a16="http://schemas.microsoft.com/office/drawing/2014/main" id="{4C37DD2E-5E2D-1F77-6F15-93C1BC41224D}"/>
+              </a:ext>
+            </a:extLst>
+          </p:cNvPr>
+          <p:cNvSpPr>
+            <a:spLocks noGrp="1"/>
+          </p:cNvSpPr>
+          <p:nvPr>
+            <p:ph idx="1"/>
           </p:nvPr>
         </p:nvSpPr>
         <p:spPr>
           <a:xfrm>
-            <a:off x="1128783" y="365125"/>
-            <a:ext cx="9934433" cy="433269"/>
+            <a:off x="777923" y="1385248"/>
+            <a:ext cx="10575878" cy="4791715"/>
           </a:xfrm>
         </p:spPr>
         <p:txBody>
           <a:bodyPr>
-            <a:noAutofit/>
+            <a:normAutofit fontScale="70000" lnSpcReduction="20000"/>
           </a:bodyPr>
           <a:lstStyle/>
           <a:p>
-            <a:r>
-              <a:rPr lang="en-IN" sz="2800" dirty="0">
-                <a:solidFill>
-                  <a:schemeClr val="tx2">
-                    <a:lumMod val="50000"/>
-                    <a:lumOff val="50000"/>
-                  </a:schemeClr>
-                </a:solidFill>
-                <a:highlight>
-                  <a:srgbClr val="FFFF00"/>
-                </a:highlight>
-              </a:rPr>
-              <a:t>OOP Concepts Used</a:t>
-            </a:r>
-          </a:p>
-        </p:txBody>
-      </p:sp>
-      <p:sp>
-        <p:nvSpPr>
-          <p:cNvPr id="3" name="Content Placeholder 2">
-            <a:extLst>
-              <a:ext uri="{FF2B5EF4-FFF2-40B4-BE49-F238E27FC236}">
-                <a16:creationId xmlns:a16="http://schemas.microsoft.com/office/drawing/2014/main" id="{F39978EC-D0CC-AD57-46B1-2643C496BC52}"/>
-              </a:ext>
-            </a:extLst>
-          </p:cNvPr>
-          <p:cNvSpPr>
-            <a:spLocks noGrp="1"/>
-          </p:cNvSpPr>
-          <p:nvPr>
-            <p:ph idx="1"/>
-          </p:nvPr>
-        </p:nvSpPr>
-        <p:spPr>
-          <a:xfrm>
-            <a:off x="612443" y="798394"/>
-            <a:ext cx="10967114" cy="5837593"/>
-          </a:xfrm>
-        </p:spPr>
-        <p:txBody>
-          <a:bodyPr>
-            <a:normAutofit fontScale="92500" lnSpcReduction="10000"/>
-          </a:bodyPr>
-          <a:lstStyle/>
-          <a:p>
-            <a:r>
-              <a:rPr lang="en-US" sz="2400" b="1" dirty="0"/>
-              <a:t>Abstraction:</a:t>
-            </a:r>
-            <a:endParaRPr lang="en-US" sz="2400" dirty="0"/>
-          </a:p>
-          <a:p>
-            <a:r>
-              <a:rPr lang="en-US" sz="2400" dirty="0"/>
-              <a:t>Implemented using the </a:t>
-            </a:r>
-            <a:r>
-              <a:rPr lang="en-US" sz="2400" b="1" dirty="0" err="1"/>
+            <a:br>
+              <a:rPr lang="en-US" dirty="0"/>
+            </a:br>
+            <a:r>
+              <a:rPr lang="en-US" dirty="0"/>
+              <a:t>User interacts with a menu-driven interface → system processes input → manages course selection using Composite Pattern.</a:t>
+            </a:r>
+          </a:p>
+          <a:p>
+            <a:r>
+              <a:rPr lang="fr-FR" dirty="0"/>
+              <a:t>User → Menu System → Course Modules (Composite Structure)</a:t>
+            </a:r>
+          </a:p>
+          <a:p>
+            <a:r>
+              <a:rPr lang="en-US" b="1" dirty="0"/>
+              <a:t>Key Classes &amp; Responsibilities:</a:t>
+            </a:r>
+            <a:endParaRPr lang="en-US" dirty="0"/>
+          </a:p>
+          <a:p>
+            <a:r>
+              <a:rPr lang="en-US" b="1" dirty="0" err="1"/>
               <a:t>CourseModule</a:t>
             </a:r>
             <a:r>
-              <a:rPr lang="en-US" sz="2400" b="1" dirty="0"/>
-              <a:t> interface</a:t>
-            </a:r>
-            <a:r>
-              <a:rPr lang="en-US" sz="2400" dirty="0"/>
+              <a:rPr lang="en-US" b="1" dirty="0"/>
+              <a:t> (Interface):</a:t>
+            </a:r>
+            <a:r>
+              <a:rPr lang="en-US" dirty="0"/>
+              <a:t> Defines common operations like </a:t>
+            </a:r>
+            <a:r>
+              <a:rPr lang="en-US" dirty="0" err="1"/>
+              <a:t>showDetails</a:t>
+            </a:r>
+            <a:r>
+              <a:rPr lang="en-US" dirty="0"/>
+              <a:t>() and </a:t>
+            </a:r>
+            <a:r>
+              <a:rPr lang="en-US" dirty="0" err="1"/>
+              <a:t>getCredits</a:t>
+            </a:r>
+            <a:r>
+              <a:rPr lang="en-US" dirty="0"/>
+              <a:t>() </a:t>
+            </a:r>
+          </a:p>
+          <a:p>
+            <a:r>
+              <a:rPr lang="en-US" b="1" dirty="0" err="1"/>
+              <a:t>IndividualCourse</a:t>
+            </a:r>
+            <a:r>
+              <a:rPr lang="en-US" b="1" dirty="0"/>
+              <a:t> (Leaf):</a:t>
+            </a:r>
+            <a:r>
+              <a:rPr lang="en-US" dirty="0"/>
+              <a:t> Represents a single course with name and credits </a:t>
+            </a:r>
+          </a:p>
+          <a:p>
+            <a:r>
+              <a:rPr lang="en-US" b="1" dirty="0" err="1"/>
+              <a:t>CourseGroup</a:t>
+            </a:r>
+            <a:r>
+              <a:rPr lang="en-US" b="1" dirty="0"/>
+              <a:t> (Composite):</a:t>
+            </a:r>
+            <a:r>
+              <a:rPr lang="en-US" dirty="0"/>
+              <a:t> Groups multiple courses/modules and manages them </a:t>
+            </a:r>
+          </a:p>
+          <a:p>
+            <a:r>
+              <a:rPr lang="en-US" b="1" dirty="0"/>
+              <a:t>Package Structure:</a:t>
+            </a:r>
+            <a:endParaRPr lang="en-US" dirty="0"/>
+          </a:p>
+          <a:p>
+            <a:r>
+              <a:rPr lang="en-US" b="1" dirty="0"/>
+              <a:t>model:</a:t>
+            </a:r>
+            <a:r>
+              <a:rPr lang="en-US" dirty="0"/>
+              <a:t> Contains </a:t>
+            </a:r>
+            <a:r>
+              <a:rPr lang="en-US" dirty="0" err="1"/>
+              <a:t>CourseModule</a:t>
+            </a:r>
+            <a:r>
+              <a:rPr lang="en-US" dirty="0"/>
+              <a:t>, </a:t>
+            </a:r>
+            <a:r>
+              <a:rPr lang="en-US" dirty="0" err="1"/>
+              <a:t>IndividualCourse</a:t>
+            </a:r>
+            <a:r>
+              <a:rPr lang="en-US" dirty="0"/>
+              <a:t>, </a:t>
+            </a:r>
+            <a:r>
+              <a:rPr lang="en-US" dirty="0" err="1"/>
+              <a:t>CourseGroup</a:t>
+            </a:r>
+            <a:r>
+              <a:rPr lang="en-US" dirty="0"/>
               <a:t> </a:t>
             </a:r>
           </a:p>
           <a:p>
             <a:r>
-              <a:rPr lang="en-US" sz="2400" dirty="0"/>
-              <a:t>Hides implementation details and exposes only essential methods like </a:t>
-            </a:r>
-            <a:r>
-              <a:rPr lang="en-US" sz="2400" dirty="0" err="1"/>
-              <a:t>showDetails</a:t>
-            </a:r>
-            <a:r>
-              <a:rPr lang="en-US" sz="2400" dirty="0"/>
-              <a:t>() and </a:t>
-            </a:r>
-            <a:r>
-              <a:rPr lang="en-US" sz="2400" dirty="0" err="1"/>
-              <a:t>getCredits</a:t>
-            </a:r>
-            <a:r>
-              <a:rPr lang="en-US" sz="2400" dirty="0"/>
-              <a:t>() </a:t>
-            </a:r>
-          </a:p>
-          <a:p>
-            <a:r>
-              <a:rPr lang="en-US" sz="2400" b="1" dirty="0"/>
-              <a:t>Inheritance:</a:t>
-            </a:r>
-            <a:endParaRPr lang="en-US" sz="2400" dirty="0"/>
-          </a:p>
-          <a:p>
-            <a:r>
-              <a:rPr lang="en-US" sz="2400" b="1" dirty="0" err="1"/>
+              <a:rPr lang="en-US" b="1" dirty="0"/>
+              <a:t>main:</a:t>
+            </a:r>
+            <a:r>
+              <a:rPr lang="en-US" dirty="0"/>
+              <a:t> Contains </a:t>
+            </a:r>
+            <a:r>
+              <a:rPr lang="en-US" dirty="0" err="1"/>
+              <a:t>CourseRegistrationSystem</a:t>
+            </a:r>
+            <a:r>
+              <a:rPr lang="en-US" dirty="0"/>
+              <a:t> (execution logic) </a:t>
+            </a:r>
+          </a:p>
+          <a:p>
+            <a:r>
+              <a:rPr lang="en-IN" dirty="0"/>
+              <a:t> </a:t>
+            </a:r>
+            <a:r>
+              <a:rPr lang="en-IN" dirty="0" err="1"/>
+              <a:t>CourseModule</a:t>
+            </a:r>
+            <a:endParaRPr lang="en-IN" dirty="0"/>
+          </a:p>
+          <a:p>
+            <a:r>
+              <a:rPr lang="en-IN" dirty="0"/>
+              <a:t>        /                         \</a:t>
+            </a:r>
+          </a:p>
+          <a:p>
+            <a:r>
+              <a:rPr lang="en-IN" dirty="0" err="1"/>
               <a:t>IndividualCourse</a:t>
             </a:r>
             <a:r>
-              <a:rPr lang="en-US" sz="2400" dirty="0"/>
-              <a:t> and </a:t>
-            </a:r>
-            <a:r>
-              <a:rPr lang="en-US" sz="2400" b="1" dirty="0" err="1"/>
+              <a:rPr lang="en-IN" dirty="0"/>
+              <a:t>  </a:t>
+            </a:r>
+            <a:r>
+              <a:rPr lang="en-IN" dirty="0" err="1"/>
               <a:t>CourseGroup</a:t>
             </a:r>
-            <a:r>
-              <a:rPr lang="en-US" sz="2400" dirty="0"/>
-              <a:t> both implement the </a:t>
-            </a:r>
-            <a:r>
-              <a:rPr lang="en-US" sz="2400" b="1" dirty="0" err="1"/>
-              <a:t>CourseModule</a:t>
-            </a:r>
-            <a:r>
-              <a:rPr lang="en-US" sz="2400" b="1" dirty="0"/>
-              <a:t> interface</a:t>
-            </a:r>
-            <a:r>
-              <a:rPr lang="en-US" sz="2400" dirty="0"/>
-              <a:t> </a:t>
-            </a:r>
-          </a:p>
-          <a:p>
-            <a:r>
-              <a:rPr lang="en-US" sz="2400" dirty="0"/>
-              <a:t>Ensures a common structure for all course types </a:t>
-            </a:r>
-          </a:p>
-          <a:p>
-            <a:r>
-              <a:rPr lang="en-US" sz="2400" b="1" dirty="0"/>
-              <a:t>Polymorphism:</a:t>
-            </a:r>
-            <a:endParaRPr lang="en-US" sz="2400" dirty="0"/>
-          </a:p>
-          <a:p>
-            <a:r>
-              <a:rPr lang="en-US" sz="2400" dirty="0"/>
-              <a:t>Same interface (</a:t>
-            </a:r>
-            <a:r>
-              <a:rPr lang="en-US" sz="2400" b="1" dirty="0" err="1"/>
-              <a:t>CourseModule</a:t>
-            </a:r>
-            <a:r>
-              <a:rPr lang="en-US" sz="2400" dirty="0"/>
-              <a:t>) is used to handle both individual courses and course groups </a:t>
-            </a:r>
-          </a:p>
-          <a:p>
-            <a:r>
-              <a:rPr lang="en-US" sz="2400" dirty="0"/>
-              <a:t>Methods like </a:t>
-            </a:r>
-            <a:r>
-              <a:rPr lang="en-US" sz="2400" dirty="0" err="1"/>
-              <a:t>showDetails</a:t>
-            </a:r>
-            <a:r>
-              <a:rPr lang="en-US" sz="2400" dirty="0"/>
-              <a:t>() behave differently based on object type </a:t>
-            </a:r>
-          </a:p>
-          <a:p>
-            <a:r>
-              <a:rPr lang="en-US" sz="2400" b="1" dirty="0"/>
-              <a:t>Design Pattern:</a:t>
-            </a:r>
-            <a:endParaRPr lang="en-US" sz="2400" dirty="0"/>
-          </a:p>
-          <a:p>
-            <a:r>
-              <a:rPr lang="en-US" sz="2400" b="1" dirty="0"/>
-              <a:t>Composite Pattern</a:t>
-            </a:r>
-            <a:r>
-              <a:rPr lang="en-US" sz="2400" dirty="0"/>
-              <a:t> </a:t>
-            </a:r>
-          </a:p>
-          <a:p>
-            <a:r>
-              <a:rPr lang="en-US" sz="2400" dirty="0"/>
-              <a:t>Allows treating individual courses and groups of courses uniformly </a:t>
-            </a:r>
-          </a:p>
-          <a:p>
-            <a:r>
-              <a:rPr lang="en-US" sz="2400" dirty="0"/>
-              <a:t>Supports hierarchical (tree-like) course structure</a:t>
-            </a:r>
-          </a:p>
-          <a:p>
             <a:endParaRPr lang="en-IN" dirty="0"/>
           </a:p>
         </p:txBody>
@@ -4054,7 +3934,7 @@
     </p:spTree>
     <p:extLst>
       <p:ext uri="{BB962C8B-B14F-4D97-AF65-F5344CB8AC3E}">
-        <p14:creationId xmlns:p14="http://schemas.microsoft.com/office/powerpoint/2010/main" val="523186988"/>
+        <p14:creationId xmlns:p14="http://schemas.microsoft.com/office/powerpoint/2010/main" val="1679849687"/>
       </p:ext>
     </p:extLst>
   </p:cSld>
@@ -4086,6 +3966,267 @@
           <p:cNvPr id="2" name="Title 1">
             <a:extLst>
               <a:ext uri="{FF2B5EF4-FFF2-40B4-BE49-F238E27FC236}">
+                <a16:creationId xmlns:a16="http://schemas.microsoft.com/office/drawing/2014/main" id="{E1750AAE-FF6D-7309-8E46-CE96AA596D16}"/>
+              </a:ext>
+            </a:extLst>
+          </p:cNvPr>
+          <p:cNvSpPr>
+            <a:spLocks noGrp="1"/>
+          </p:cNvSpPr>
+          <p:nvPr>
+            <p:ph type="title"/>
+          </p:nvPr>
+        </p:nvSpPr>
+        <p:spPr>
+          <a:xfrm>
+            <a:off x="862652" y="283238"/>
+            <a:ext cx="9934433" cy="433269"/>
+          </a:xfrm>
+        </p:spPr>
+        <p:txBody>
+          <a:bodyPr>
+            <a:noAutofit/>
+          </a:bodyPr>
+          <a:lstStyle/>
+          <a:p>
+            <a:r>
+              <a:rPr lang="en-IN" sz="2800" dirty="0">
+                <a:solidFill>
+                  <a:schemeClr val="tx2">
+                    <a:lumMod val="50000"/>
+                    <a:lumOff val="50000"/>
+                  </a:schemeClr>
+                </a:solidFill>
+                <a:highlight>
+                  <a:srgbClr val="FFFF00"/>
+                </a:highlight>
+              </a:rPr>
+              <a:t>OOP Concepts Used</a:t>
+            </a:r>
+          </a:p>
+        </p:txBody>
+      </p:sp>
+      <p:sp>
+        <p:nvSpPr>
+          <p:cNvPr id="3" name="Content Placeholder 2">
+            <a:extLst>
+              <a:ext uri="{FF2B5EF4-FFF2-40B4-BE49-F238E27FC236}">
+                <a16:creationId xmlns:a16="http://schemas.microsoft.com/office/drawing/2014/main" id="{F39978EC-D0CC-AD57-46B1-2643C496BC52}"/>
+              </a:ext>
+            </a:extLst>
+          </p:cNvPr>
+          <p:cNvSpPr>
+            <a:spLocks noGrp="1"/>
+          </p:cNvSpPr>
+          <p:nvPr>
+            <p:ph idx="1"/>
+          </p:nvPr>
+        </p:nvSpPr>
+        <p:spPr>
+          <a:xfrm>
+            <a:off x="612443" y="798394"/>
+            <a:ext cx="10967114" cy="5837593"/>
+          </a:xfrm>
+        </p:spPr>
+        <p:txBody>
+          <a:bodyPr>
+            <a:normAutofit fontScale="92500" lnSpcReduction="10000"/>
+          </a:bodyPr>
+          <a:lstStyle/>
+          <a:p>
+            <a:r>
+              <a:rPr lang="en-US" sz="2400" b="1" dirty="0"/>
+              <a:t>Abstraction:</a:t>
+            </a:r>
+            <a:endParaRPr lang="en-US" sz="2400" dirty="0"/>
+          </a:p>
+          <a:p>
+            <a:r>
+              <a:rPr lang="en-US" sz="2400" dirty="0"/>
+              <a:t>Implemented using the </a:t>
+            </a:r>
+            <a:r>
+              <a:rPr lang="en-US" sz="2400" b="1" dirty="0" err="1"/>
+              <a:t>CourseModule</a:t>
+            </a:r>
+            <a:r>
+              <a:rPr lang="en-US" sz="2400" b="1" dirty="0"/>
+              <a:t> interface</a:t>
+            </a:r>
+            <a:r>
+              <a:rPr lang="en-US" sz="2400" dirty="0"/>
+              <a:t> </a:t>
+            </a:r>
+          </a:p>
+          <a:p>
+            <a:r>
+              <a:rPr lang="en-US" sz="2400" dirty="0"/>
+              <a:t>Hides implementation details and exposes only essential methods like </a:t>
+            </a:r>
+            <a:r>
+              <a:rPr lang="en-US" sz="2400" dirty="0" err="1"/>
+              <a:t>showDetails</a:t>
+            </a:r>
+            <a:r>
+              <a:rPr lang="en-US" sz="2400" dirty="0"/>
+              <a:t>() and </a:t>
+            </a:r>
+            <a:r>
+              <a:rPr lang="en-US" sz="2400" dirty="0" err="1"/>
+              <a:t>getCredits</a:t>
+            </a:r>
+            <a:r>
+              <a:rPr lang="en-US" sz="2400" dirty="0"/>
+              <a:t>() </a:t>
+            </a:r>
+          </a:p>
+          <a:p>
+            <a:r>
+              <a:rPr lang="en-US" sz="2400" b="1" dirty="0"/>
+              <a:t>Inheritance:</a:t>
+            </a:r>
+            <a:endParaRPr lang="en-US" sz="2400" dirty="0"/>
+          </a:p>
+          <a:p>
+            <a:r>
+              <a:rPr lang="en-US" sz="2400" b="1" dirty="0" err="1"/>
+              <a:t>IndividualCourse</a:t>
+            </a:r>
+            <a:r>
+              <a:rPr lang="en-US" sz="2400" dirty="0"/>
+              <a:t> and </a:t>
+            </a:r>
+            <a:r>
+              <a:rPr lang="en-US" sz="2400" b="1" dirty="0" err="1"/>
+              <a:t>CourseGroup</a:t>
+            </a:r>
+            <a:r>
+              <a:rPr lang="en-US" sz="2400" dirty="0"/>
+              <a:t> both implement the </a:t>
+            </a:r>
+            <a:r>
+              <a:rPr lang="en-US" sz="2400" b="1" dirty="0" err="1"/>
+              <a:t>CourseModule</a:t>
+            </a:r>
+            <a:r>
+              <a:rPr lang="en-US" sz="2400" b="1" dirty="0"/>
+              <a:t> interface</a:t>
+            </a:r>
+            <a:r>
+              <a:rPr lang="en-US" sz="2400" dirty="0"/>
+              <a:t> </a:t>
+            </a:r>
+          </a:p>
+          <a:p>
+            <a:r>
+              <a:rPr lang="en-US" sz="2400" dirty="0"/>
+              <a:t>Ensures a common structure for all course types </a:t>
+            </a:r>
+          </a:p>
+          <a:p>
+            <a:r>
+              <a:rPr lang="en-US" sz="2400" b="1" dirty="0"/>
+              <a:t>Polymorphism:</a:t>
+            </a:r>
+            <a:endParaRPr lang="en-US" sz="2400" dirty="0"/>
+          </a:p>
+          <a:p>
+            <a:r>
+              <a:rPr lang="en-US" sz="2400" dirty="0"/>
+              <a:t>Same interface (</a:t>
+            </a:r>
+            <a:r>
+              <a:rPr lang="en-US" sz="2400" b="1" dirty="0" err="1"/>
+              <a:t>CourseModule</a:t>
+            </a:r>
+            <a:r>
+              <a:rPr lang="en-US" sz="2400" dirty="0"/>
+              <a:t>) is used to handle both individual courses and course groups </a:t>
+            </a:r>
+          </a:p>
+          <a:p>
+            <a:r>
+              <a:rPr lang="en-US" sz="2400" dirty="0"/>
+              <a:t>Methods like </a:t>
+            </a:r>
+            <a:r>
+              <a:rPr lang="en-US" sz="2400" dirty="0" err="1"/>
+              <a:t>showDetails</a:t>
+            </a:r>
+            <a:r>
+              <a:rPr lang="en-US" sz="2400" dirty="0"/>
+              <a:t>() behave differently based on object type </a:t>
+            </a:r>
+          </a:p>
+          <a:p>
+            <a:r>
+              <a:rPr lang="en-US" sz="2400" b="1" dirty="0"/>
+              <a:t>Design Pattern:</a:t>
+            </a:r>
+            <a:endParaRPr lang="en-US" sz="2400" dirty="0"/>
+          </a:p>
+          <a:p>
+            <a:r>
+              <a:rPr lang="en-US" sz="2400" b="1" dirty="0"/>
+              <a:t>Composite Pattern</a:t>
+            </a:r>
+            <a:r>
+              <a:rPr lang="en-US" sz="2400" dirty="0"/>
+              <a:t> </a:t>
+            </a:r>
+          </a:p>
+          <a:p>
+            <a:r>
+              <a:rPr lang="en-US" sz="2400" dirty="0"/>
+              <a:t>Allows treating individual courses and groups of courses uniformly </a:t>
+            </a:r>
+          </a:p>
+          <a:p>
+            <a:r>
+              <a:rPr lang="en-US" sz="2400" dirty="0"/>
+              <a:t>Supports hierarchical (tree-like) course structure</a:t>
+            </a:r>
+          </a:p>
+          <a:p>
+            <a:endParaRPr lang="en-IN" dirty="0"/>
+          </a:p>
+        </p:txBody>
+      </p:sp>
+    </p:spTree>
+    <p:extLst>
+      <p:ext uri="{BB962C8B-B14F-4D97-AF65-F5344CB8AC3E}">
+        <p14:creationId xmlns:p14="http://schemas.microsoft.com/office/powerpoint/2010/main" val="523186988"/>
+      </p:ext>
+    </p:extLst>
+  </p:cSld>
+  <p:clrMapOvr>
+    <a:masterClrMapping/>
+  </p:clrMapOvr>
+</p:sld>
+</file>
+
+<file path=ppt/slides/slide5.xml><?xml version="1.0" encoding="utf-8"?>
+<p:sld xmlns:a="http://schemas.openxmlformats.org/drawingml/2006/main" xmlns:r="http://schemas.openxmlformats.org/officeDocument/2006/relationships" xmlns:p="http://schemas.openxmlformats.org/presentationml/2006/main">
+  <p:cSld>
+    <p:spTree>
+      <p:nvGrpSpPr>
+        <p:cNvPr id="1" name=""/>
+        <p:cNvGrpSpPr/>
+        <p:nvPr/>
+      </p:nvGrpSpPr>
+      <p:grpSpPr>
+        <a:xfrm>
+          <a:off x="0" y="0"/>
+          <a:ext cx="0" cy="0"/>
+          <a:chOff x="0" y="0"/>
+          <a:chExt cx="0" cy="0"/>
+        </a:xfrm>
+      </p:grpSpPr>
+      <p:sp>
+        <p:nvSpPr>
+          <p:cNvPr id="2" name="Title 1">
+            <a:extLst>
+              <a:ext uri="{FF2B5EF4-FFF2-40B4-BE49-F238E27FC236}">
                 <a16:creationId xmlns:a16="http://schemas.microsoft.com/office/drawing/2014/main" id="{ADC8BC82-3569-B978-E261-BF80F0A35BE2}"/>
               </a:ext>
             </a:extLst>
@@ -4300,7 +4441,7 @@
 </p:sld>
 </file>
 
-<file path=ppt/slides/slide5.xml><?xml version="1.0" encoding="utf-8"?>
+<file path=ppt/slides/slide6.xml><?xml version="1.0" encoding="utf-8"?>
 <p:sld xmlns:a="http://schemas.openxmlformats.org/drawingml/2006/main" xmlns:r="http://schemas.openxmlformats.org/officeDocument/2006/relationships" xmlns:p="http://schemas.openxmlformats.org/presentationml/2006/main">
   <p:cSld>
     <p:spTree>

</xml_diff>